<commit_message>
Add PPT pattern taxonomy and coherence proof
</commit_message>
<xml_diff>
--- a/artifacts/mdpr-integrated/mdpr-build/deck.pptx
+++ b/artifacts/mdpr-integrated/mdpr-build/deck.pptx
@@ -3130,7 +3130,7 @@
                 <a:ea typeface="Pretendard" pitchFamily="34" charset="-122"/>
                 <a:cs typeface="Pretendard" pitchFamily="34" charset="-120"/>
               </a:rPr>
-              <a:t>	parser, slide splitting, layout selection, editable PowerPoint rendering, theme colors, charts, tables, diagrams, and text fit.</a:t>
+              <a:t>  parser, slide splitting, layout selection, editable PowerPoint rendering, theme colors, charts, tables, diagrams, and text fit.</a:t>
             </a:r>
             <a:endParaRPr lang="en-US" sz="2200" dirty="0"/>
           </a:p>
@@ -3353,7 +3353,7 @@
                 <a:ea typeface="Pretendard" pitchFamily="34" charset="-122"/>
                 <a:cs typeface="Pretendard" pitchFamily="34" charset="-120"/>
               </a:rPr>
-              <a:t>	optional agent hints that describe emphasis, importance, and likely visual intent before MDPR makes deterministic choices.</a:t>
+              <a:t>  optional agent hints that describe emphasis, importance, and likely visual intent before MDPR makes deterministic choices.</a:t>
             </a:r>
             <a:endParaRPr lang="en-US" sz="2200" dirty="0"/>
           </a:p>
@@ -3495,7 +3495,7 @@
                 <a:ea typeface="Pretendard" pitchFamily="34" charset="-122"/>
                 <a:cs typeface="Pretendard" pitchFamily="34" charset="-120"/>
               </a:rPr>
-              <a:t>	PowerPoint export, PNG previews, minimum font checks, and shape-level inspection.</a:t>
+              <a:t>  PowerPoint export, PNG previews, minimum font checks, and shape-level inspection.</a:t>
             </a:r>
             <a:endParaRPr lang="en-US" sz="2200" dirty="0"/>
           </a:p>
@@ -3718,7 +3718,7 @@
                 <a:ea typeface="Pretendard" pitchFamily="34" charset="-122"/>
                 <a:cs typeface="Pretendard" pitchFamily="34" charset="-120"/>
               </a:rPr>
-              <a:t>	one Markdown source can produce coherent PPTX and HTML without a separate handmade renderer.</a:t>
+              <a:t>  one Markdown source can produce coherent PPTX and HTML without a separate handmade renderer.</a:t>
             </a:r>
             <a:endParaRPr lang="en-US" sz="2200" dirty="0"/>
           </a:p>
@@ -5321,7 +5321,7 @@
                         <a:buNone/>
                       </a:pPr>
                       <a:r>
-                        <a:rPr lang="en-US" sz="1500" dirty="0">
+                        <a:rPr lang="en-US" sz="1500" b="1" dirty="0">
                           <a:solidFill>
                             <a:srgbClr val="1F2937"/>
                           </a:solidFill>
@@ -5518,7 +5518,7 @@
                         <a:buNone/>
                       </a:pPr>
                       <a:r>
-                        <a:rPr lang="en-US" sz="1500" dirty="0">
+                        <a:rPr lang="en-US" sz="1500" b="1" dirty="0">
                           <a:solidFill>
                             <a:srgbClr val="1F2937"/>
                           </a:solidFill>
@@ -5572,6 +5572,11 @@
                       <a:headEnd type="none" w="med" len="med"/>
                       <a:tailEnd type="none" w="med" len="med"/>
                     </a:lnB>
+                    <a:solidFill>
+                      <a:srgbClr val="FBF7F2">
+                        <a:alpha val="80000"/>
+                      </a:srgbClr>
+                    </a:solidFill>
                   </a:tcPr>
                 </a:tc>
                 <a:tc>
@@ -5637,6 +5642,11 @@
                       <a:headEnd type="none" w="med" len="med"/>
                       <a:tailEnd type="none" w="med" len="med"/>
                     </a:lnB>
+                    <a:solidFill>
+                      <a:srgbClr val="FBF7F2">
+                        <a:alpha val="80000"/>
+                      </a:srgbClr>
+                    </a:solidFill>
                   </a:tcPr>
                 </a:tc>
                 <a:tc>
@@ -5702,6 +5712,11 @@
                       <a:headEnd type="none" w="med" len="med"/>
                       <a:tailEnd type="none" w="med" len="med"/>
                     </a:lnB>
+                    <a:solidFill>
+                      <a:srgbClr val="FBF7F2">
+                        <a:alpha val="80000"/>
+                      </a:srgbClr>
+                    </a:solidFill>
                   </a:tcPr>
                 </a:tc>
               </a:tr>
@@ -5715,7 +5730,7 @@
                         <a:buNone/>
                       </a:pPr>
                       <a:r>
-                        <a:rPr lang="en-US" sz="1500" dirty="0">
+                        <a:rPr lang="en-US" sz="1500" b="1" dirty="0">
                           <a:solidFill>
                             <a:srgbClr val="1F2937"/>
                           </a:solidFill>
@@ -5912,7 +5927,7 @@
                         <a:buNone/>
                       </a:pPr>
                       <a:r>
-                        <a:rPr lang="en-US" sz="1500" dirty="0">
+                        <a:rPr lang="en-US" sz="1500" b="1" dirty="0">
                           <a:solidFill>
                             <a:srgbClr val="1F2937"/>
                           </a:solidFill>
@@ -5966,6 +5981,11 @@
                       <a:headEnd type="none" w="med" len="med"/>
                       <a:tailEnd type="none" w="med" len="med"/>
                     </a:lnB>
+                    <a:solidFill>
+                      <a:srgbClr val="FBF7F2">
+                        <a:alpha val="80000"/>
+                      </a:srgbClr>
+                    </a:solidFill>
                   </a:tcPr>
                 </a:tc>
                 <a:tc>
@@ -6031,6 +6051,11 @@
                       <a:headEnd type="none" w="med" len="med"/>
                       <a:tailEnd type="none" w="med" len="med"/>
                     </a:lnB>
+                    <a:solidFill>
+                      <a:srgbClr val="FBF7F2">
+                        <a:alpha val="80000"/>
+                      </a:srgbClr>
+                    </a:solidFill>
                   </a:tcPr>
                 </a:tc>
                 <a:tc>
@@ -6096,6 +6121,11 @@
                       <a:headEnd type="none" w="med" len="med"/>
                       <a:tailEnd type="none" w="med" len="med"/>
                     </a:lnB>
+                    <a:solidFill>
+                      <a:srgbClr val="FBF7F2">
+                        <a:alpha val="80000"/>
+                      </a:srgbClr>
+                    </a:solidFill>
                   </a:tcPr>
                 </a:tc>
               </a:tr>
@@ -6225,7 +6255,7 @@
         <p:spPr>
           <a:xfrm>
             <a:off x="822960" y="1572768"/>
-            <a:ext cx="6629400" cy="73152"/>
+            <a:ext cx="8092440" cy="73152"/>
           </a:xfrm>
           <a:prstGeom prst="rect">
             <a:avLst/>
@@ -6251,30 +6281,25 @@
         </p:nvSpPr>
         <p:spPr>
           <a:xfrm>
-            <a:off x="7955280" y="1993392"/>
-            <a:ext cx="2139696" cy="2139696"/>
+            <a:off x="9583644" y="2250156"/>
+            <a:ext cx="227532" cy="293895"/>
           </a:xfrm>
           <a:prstGeom prst="roundRect">
             <a:avLst>
-              <a:gd name="adj" fmla="val 3419"/>
+              <a:gd name="adj" fmla="val 16075"/>
             </a:avLst>
           </a:prstGeom>
           <a:solidFill>
-            <a:srgbClr val="FBF7F2"/>
-          </a:solidFill>
-          <a:ln w="12700">
-            <a:solidFill>
-              <a:srgbClr val="D6D0C2"/>
-            </a:solidFill>
-            <a:prstDash val="solid"/>
-          </a:ln>
-          <a:effectLst>
-            <a:outerShdw sx="100000" sy="100000" kx="0" ky="0" algn="bl" rotWithShape="0" blurRad="12700" dist="50800" dir="2700000">
-              <a:srgbClr val="000000">
-                <a:alpha val="8000"/>
-              </a:srgbClr>
-            </a:outerShdw>
-          </a:effectLst>
+            <a:srgbClr val="1F2937"/>
+          </a:solidFill>
+          <a:ln w="12700">
+            <a:solidFill>
+              <a:srgbClr val="1F2937">
+                <a:alpha val="0"/>
+              </a:srgbClr>
+            </a:solidFill>
+            <a:prstDash val="solid"/>
+          </a:ln>
         </p:spPr>
       </p:sp>
       <p:sp>
@@ -6285,20 +6310,18 @@
         </p:nvSpPr>
         <p:spPr>
           <a:xfrm>
-            <a:off x="8511601" y="2464125"/>
-            <a:ext cx="575150" cy="742902"/>
-          </a:xfrm>
-          <a:prstGeom prst="roundRect">
-            <a:avLst>
-              <a:gd name="adj" fmla="val 6359"/>
-            </a:avLst>
-          </a:prstGeom>
-          <a:solidFill>
-            <a:srgbClr val="1F2937"/>
-          </a:solidFill>
-          <a:ln w="12700">
-            <a:solidFill>
-              <a:srgbClr val="1F2937">
+            <a:off x="9640527" y="2326000"/>
+            <a:ext cx="118506" cy="16591"/>
+          </a:xfrm>
+          <a:prstGeom prst="rect">
+            <a:avLst/>
+          </a:prstGeom>
+          <a:solidFill>
+            <a:srgbClr val="F7F3EF"/>
+          </a:solidFill>
+          <a:ln w="12700">
+            <a:solidFill>
+              <a:srgbClr val="F7F3EF">
                 <a:alpha val="0"/>
               </a:srgbClr>
             </a:solidFill>
@@ -6314,18 +6337,18 @@
         </p:nvSpPr>
         <p:spPr>
           <a:xfrm>
-            <a:off x="8655389" y="2655842"/>
-            <a:ext cx="299557" cy="41938"/>
-          </a:xfrm>
-          <a:prstGeom prst="rect">
-            <a:avLst/>
-          </a:prstGeom>
-          <a:solidFill>
-            <a:srgbClr val="FBF7F2"/>
-          </a:solidFill>
-          <a:ln w="12700">
-            <a:solidFill>
-              <a:srgbClr val="FBF7F2">
+            <a:off x="9640527" y="2387623"/>
+            <a:ext cx="118506" cy="16591"/>
+          </a:xfrm>
+          <a:prstGeom prst="rect">
+            <a:avLst/>
+          </a:prstGeom>
+          <a:solidFill>
+            <a:srgbClr val="F7F3EF"/>
+          </a:solidFill>
+          <a:ln w="12700">
+            <a:solidFill>
+              <a:srgbClr val="F7F3EF">
                 <a:alpha val="0"/>
               </a:srgbClr>
             </a:solidFill>
@@ -6341,18 +6364,18 @@
         </p:nvSpPr>
         <p:spPr>
           <a:xfrm>
-            <a:off x="8655389" y="2811612"/>
-            <a:ext cx="299557" cy="41938"/>
-          </a:xfrm>
-          <a:prstGeom prst="rect">
-            <a:avLst/>
-          </a:prstGeom>
-          <a:solidFill>
-            <a:srgbClr val="FBF7F2"/>
-          </a:solidFill>
-          <a:ln w="12700">
-            <a:solidFill>
-              <a:srgbClr val="FBF7F2">
+            <a:off x="9640527" y="2449246"/>
+            <a:ext cx="118506" cy="16591"/>
+          </a:xfrm>
+          <a:prstGeom prst="rect">
+            <a:avLst/>
+          </a:prstGeom>
+          <a:solidFill>
+            <a:srgbClr val="F7F3EF"/>
+          </a:solidFill>
+          <a:ln w="12700">
+            <a:solidFill>
+              <a:srgbClr val="F7F3EF">
                 <a:alpha val="0"/>
               </a:srgbClr>
             </a:solidFill>
@@ -6368,35 +6391,8 @@
         </p:nvSpPr>
         <p:spPr>
           <a:xfrm>
-            <a:off x="8655389" y="2967382"/>
-            <a:ext cx="299557" cy="41938"/>
-          </a:xfrm>
-          <a:prstGeom prst="rect">
-            <a:avLst/>
-          </a:prstGeom>
-          <a:solidFill>
-            <a:srgbClr val="FBF7F2"/>
-          </a:solidFill>
-          <a:ln w="12700">
-            <a:solidFill>
-              <a:srgbClr val="FBF7F2">
-                <a:alpha val="0"/>
-              </a:srgbClr>
-            </a:solidFill>
-            <a:prstDash val="solid"/>
-          </a:ln>
-        </p:spPr>
-      </p:sp>
-      <p:sp>
-        <p:nvSpPr>
-          <p:cNvPr id="11" name="Shape 9"/>
-          <p:cNvSpPr/>
-          <p:nvPr/>
-        </p:nvSpPr>
-        <p:spPr>
-          <a:xfrm>
             <a:off x="822960" y="1572768"/>
-            <a:ext cx="6629400" cy="3310128"/>
+            <a:ext cx="8092440" cy="3310128"/>
           </a:xfrm>
           <a:prstGeom prst="roundRect">
             <a:avLst>
@@ -6418,7 +6414,7 @@
       </p:sp>
       <p:sp>
         <p:nvSpPr>
-          <p:cNvPr id="12" name="Text 10"/>
+          <p:cNvPr id="11" name="Text 9"/>
           <p:cNvSpPr txBox="1"/>
           <p:nvPr/>
         </p:nvSpPr>
@@ -6462,14 +6458,14 @@
       </p:sp>
       <p:sp>
         <p:nvSpPr>
-          <p:cNvPr id="13" name="Text 11"/>
+          <p:cNvPr id="12" name="Text 10"/>
           <p:cNvSpPr txBox="1"/>
           <p:nvPr/>
         </p:nvSpPr>
         <p:spPr>
           <a:xfrm>
             <a:off x="1115568" y="1773936"/>
-            <a:ext cx="6044184" cy="2907792"/>
+            <a:ext cx="7507224" cy="2907792"/>
           </a:xfrm>
           <a:prstGeom prst="rect">
             <a:avLst/>
@@ -9186,7 +9182,7 @@
         <p:spPr>
           <a:xfrm>
             <a:off x="822960" y="1572768"/>
-            <a:ext cx="6629400" cy="73152"/>
+            <a:ext cx="8092440" cy="73152"/>
           </a:xfrm>
           <a:prstGeom prst="rect">
             <a:avLst/>
@@ -9211,31 +9207,24 @@
           <p:nvPr/>
         </p:nvSpPr>
         <p:spPr>
-          <a:xfrm>
-            <a:off x="7955280" y="1993392"/>
-            <a:ext cx="2139696" cy="2139696"/>
-          </a:xfrm>
-          <a:prstGeom prst="roundRect">
-            <a:avLst>
-              <a:gd name="adj" fmla="val 3419"/>
-            </a:avLst>
-          </a:prstGeom>
-          <a:solidFill>
-            <a:srgbClr val="FBF7F2"/>
-          </a:solidFill>
-          <a:ln w="12700">
-            <a:solidFill>
-              <a:srgbClr val="D6D0C2"/>
-            </a:solidFill>
-            <a:prstDash val="solid"/>
-          </a:ln>
-          <a:effectLst>
-            <a:outerShdw sx="100000" sy="100000" kx="0" ky="0" algn="bl" rotWithShape="0" blurRad="12700" dist="50800" dir="2700000">
-              <a:srgbClr val="000000">
-                <a:alpha val="8000"/>
-              </a:srgbClr>
-            </a:outerShdw>
-          </a:effectLst>
+          <a:xfrm rot="10800000">
+            <a:off x="9583644" y="2250156"/>
+            <a:ext cx="260714" cy="308116"/>
+          </a:xfrm>
+          <a:prstGeom prst="pentagon">
+            <a:avLst/>
+          </a:prstGeom>
+          <a:solidFill>
+            <a:srgbClr val="1F2937"/>
+          </a:solidFill>
+          <a:ln w="12700">
+            <a:solidFill>
+              <a:srgbClr val="1F2937">
+                <a:alpha val="0"/>
+              </a:srgbClr>
+            </a:solidFill>
+            <a:prstDash val="solid"/>
+          </a:ln>
         </p:spPr>
       </p:sp>
       <p:sp>
@@ -9245,19 +9234,19 @@
           <p:nvPr/>
         </p:nvSpPr>
         <p:spPr>
-          <a:xfrm rot="10800000">
-            <a:off x="8511601" y="2464125"/>
-            <a:ext cx="659026" cy="778849"/>
-          </a:xfrm>
-          <a:prstGeom prst="pentagon">
-            <a:avLst/>
-          </a:prstGeom>
-          <a:solidFill>
-            <a:srgbClr val="1F2937"/>
-          </a:solidFill>
-          <a:ln w="12700">
-            <a:solidFill>
-              <a:srgbClr val="1F2937">
+          <a:xfrm>
+            <a:off x="9687929" y="2307039"/>
+            <a:ext cx="47402" cy="132727"/>
+          </a:xfrm>
+          <a:prstGeom prst="rect">
+            <a:avLst/>
+          </a:prstGeom>
+          <a:solidFill>
+            <a:srgbClr val="F7F3EF"/>
+          </a:solidFill>
+          <a:ln w="12700">
+            <a:solidFill>
+              <a:srgbClr val="F7F3EF">
                 <a:alpha val="0"/>
               </a:srgbClr>
             </a:solidFill>
@@ -9273,35 +9262,8 @@
         </p:nvSpPr>
         <p:spPr>
           <a:xfrm>
-            <a:off x="8775212" y="2607913"/>
-            <a:ext cx="119823" cy="335504"/>
-          </a:xfrm>
-          <a:prstGeom prst="rect">
-            <a:avLst/>
-          </a:prstGeom>
-          <a:solidFill>
-            <a:srgbClr val="FBF7F2"/>
-          </a:solidFill>
-          <a:ln w="12700">
-            <a:solidFill>
-              <a:srgbClr val="FBF7F2">
-                <a:alpha val="0"/>
-              </a:srgbClr>
-            </a:solidFill>
-            <a:prstDash val="solid"/>
-          </a:ln>
-        </p:spPr>
-      </p:sp>
-      <p:sp>
-        <p:nvSpPr>
-          <p:cNvPr id="9" name="Shape 7"/>
-          <p:cNvSpPr/>
-          <p:nvPr/>
-        </p:nvSpPr>
-        <p:spPr>
-          <a:xfrm>
             <a:off x="822960" y="1572768"/>
-            <a:ext cx="6629400" cy="3310128"/>
+            <a:ext cx="8092440" cy="3310128"/>
           </a:xfrm>
           <a:prstGeom prst="roundRect">
             <a:avLst>
@@ -9323,7 +9285,7 @@
       </p:sp>
       <p:sp>
         <p:nvSpPr>
-          <p:cNvPr id="10" name="Text 8"/>
+          <p:cNvPr id="9" name="Text 7"/>
           <p:cNvSpPr txBox="1"/>
           <p:nvPr/>
         </p:nvSpPr>
@@ -9367,14 +9329,14 @@
       </p:sp>
       <p:sp>
         <p:nvSpPr>
-          <p:cNvPr id="11" name="Text 9"/>
+          <p:cNvPr id="10" name="Text 8"/>
           <p:cNvSpPr txBox="1"/>
           <p:nvPr/>
         </p:nvSpPr>
         <p:spPr>
           <a:xfrm>
             <a:off x="1115568" y="1773936"/>
-            <a:ext cx="6044184" cy="2907792"/>
+            <a:ext cx="7507224" cy="2907792"/>
           </a:xfrm>
           <a:prstGeom prst="rect">
             <a:avLst/>

</xml_diff>